<commit_message>
Semester 1 Week 01: learning path, answers notebook, notebook and slide corrections
- README: ordered learning path, prerequisites, outcomes, staff notes for the corrections
- New 4 Tutorial Answers/Week 1 Tutorial - Answers.ipynb (Exercises 1-8)
- NumPy notebook: swapped .dot()/@ labels fixed, singular-matrix paragraph finished, typos
- Both notebooks: "np.linalg.det()" comment corrected to np.linalg.inv()
- Tutorial: Ex 4/8 name the exercise they plot, empty last cell removed, typos
- Slides (.pptx only; PDF to be re-exported): slide 24 equation x - y = 1 to match its graph,
  slide 24 wording, slide 18 "Sub (3) into (2)", slide 2 "Let's start"
- Semester 1 and top-level README rows for Week 01 updated

Co-Authored-By: Claude Opus 5.5 <noreply@anthropic.com>
Claude-Session: https://claude.ai/code/session_01QngVpgZbWjCpreCbzxnZzh
</commit_message>
<xml_diff>
--- a/content/Lectures/Semester 1/Week 01 - Introduction to Operational Research/5 Source Files/Week 1 - Introduction to Operations Research.pptx
+++ b/content/Lectures/Semester 1/Week 01 - Introduction to Operational Research/5 Source Files/Week 1 - Introduction to Operations Research.pptx
@@ -16441,7 +16441,7 @@
                 </a:pPr>
                 <a:r>
                   <a:rPr lang="en-GB" sz="1800" dirty="0"/>
-                  <a:t>Sub (1) into (2)</a:t>
+                  <a:t>Sub (3) into (2)</a:t>
                 </a:r>
               </a:p>
               <a:p>
@@ -17830,7 +17830,7 @@
           <a:p>
             <a:r>
               <a:rPr lang="en-GB" dirty="0"/>
-              <a:t>Let’ start with a look at the module handbook.</a:t>
+              <a:t>Let’s start with a look at the module handbook.</a:t>
             </a:r>
           </a:p>
           <a:p>
@@ -23074,7 +23074,7 @@
                         <a:rPr lang="en-GB" b="0" i="1" smtClean="0">
                           <a:latin typeface="Cambria Math" panose="02040503050406030204" pitchFamily="18" charset="0"/>
                         </a:rPr>
-                        <m:t>=0</m:t>
+                        <m:t>=1</m:t>
                       </m:r>
                     </m:oMath>
                   </m:oMathPara>
@@ -23128,7 +23128,7 @@
                 </a:pPr>
                 <a:r>
                   <a:rPr lang="en-GB" dirty="0"/>
-                  <a:t>Has no solution! i.e. something that solves all equations simultaneously!</a:t>
+                  <a:t>Has no solution! i.e. no point solves all three equations simultaneously!</a:t>
                 </a:r>
               </a:p>
               <a:p>

</xml_diff>